<commit_message>
Niumee CW26-27 report - corrected with real Outlook data
</commit_message>
<xml_diff>
--- a/Niumee/Kaizen-CW26-27-Niumee-Weekly-Report.pptx
+++ b/Niumee/Kaizen-CW26-27-Niumee-Weekly-Report.pptx
@@ -5571,7 +5571,7 @@
                 </a:solidFill>
                 <a:latin typeface="Avenir Book" panose="02000503020000020003"/>
               </a:rPr>
-              <a:t>Deploy SOP knowledge base into bot (57 treatments extracted, RAG system ready to integrate)</a:t>
+              <a:t>Implement re-booking reminder rules into the automation (rules document received, build ready)</a:t>
             </a:r>
           </a:p>
           <a:p>
@@ -5601,7 +5601,7 @@
                 </a:solidFill>
                 <a:latin typeface="Avenir Book" panose="02000503020000020003"/>
               </a:rPr>
-              <a:t>Run Clarissa's full 18-question regression test; fix staff, deposit, and package answers</a:t>
+              <a:t>Wire SOP knowledge base into the live bot - 57 treatments extracted, RAG system ready to deploy</a:t>
             </a:r>
           </a:p>
           <a:p>
@@ -5631,7 +5631,7 @@
                 </a:solidFill>
                 <a:latin typeface="Avenir Book" panose="02000503020000020003"/>
               </a:rPr>
-              <a:t>Improve GEO visibility: Niumee answers in ChatGPT, Claude, and Perplexity search results</a:t>
+              <a:t>Run Clarissa's 18-question regression test; fix staff assignments via Zenoti Employees API</a:t>
             </a:r>
           </a:p>
         </p:txBody>
@@ -5690,7 +5690,7 @@
                 </a:solidFill>
                 <a:latin typeface="Avenir Book" panose="02000503020000020003"/>
               </a:rPr>
-              <a:t>Phone system API connected - live tracker shows real-time missed calls with patient names</a:t>
+              <a:t>SOP updated + Donna's reminder rules received (June 30) - re-booking cadence per service now defined</a:t>
             </a:r>
           </a:p>
           <a:p>
@@ -5720,7 +5720,7 @@
                 </a:solidFill>
                 <a:latin typeface="Avenir Book" panose="02000503020000020003"/>
               </a:rPr>
-              <a:t>KPI dashboard rebuilt: 90-day revenue by category, 4 weekly trend charts; load cut from 90s to 16s</a:t>
+              <a:t>Phone system API live - real-time missed-call tracker with Zenoti name resolution, TEST recovery active</a:t>
             </a:r>
           </a:p>
           <a:p>
@@ -5750,7 +5750,7 @@
                 </a:solidFill>
                 <a:latin typeface="Avenir Book" panose="02000503020000020003"/>
               </a:rPr>
-              <a:t>WhatsApp bot: English + Maltese only; next available slot fixed; injectables route to consultation</a:t>
+              <a:t>KPI dashboard rebuilt: 90-day revenue by category + 4 weekly trend charts; load time 90s -&gt; 16s</a:t>
             </a:r>
           </a:p>
         </p:txBody>
@@ -6262,7 +6262,7 @@
                           <a:ea typeface="+mn-ea"/>
                           <a:cs typeface="+mn-cs"/>
                         </a:rPr>
-                        <a:t>KPI dashboard live - weekly and 90-day views</a:t>
+                        <a:t>KPI dashboard live - weekly and 90-day revenue views</a:t>
                       </a:r>
                     </a:p>
                   </a:txBody>
@@ -6529,7 +6529,7 @@
                           <a:ea typeface="+mn-ea"/>
                           <a:cs typeface="+mn-cs"/>
                         </a:rPr>
-                        <a:t>Live in production</a:t>
+                        <a:t>Live; reminder rules received from Donna, integration next</a:t>
                       </a:r>
                     </a:p>
                   </a:txBody>
@@ -6796,7 +6796,7 @@
                           <a:ea typeface="+mn-ea"/>
                           <a:cs typeface="+mn-cs"/>
                         </a:rPr>
-                        <a:t>Phone API live; tracker operational in TEST mode</a:t>
+                        <a:t>Phone API live; tracker in TEST mode, go-live pending</a:t>
                       </a:r>
                     </a:p>
                   </a:txBody>
@@ -7063,7 +7063,7 @@
                           <a:ea typeface="+mn-ea"/>
                           <a:cs typeface="+mn-cs"/>
                         </a:rPr>
-                        <a:t>90% done; SOP RAG integration next</a:t>
+                        <a:t>SOP KB built (57 treatments); RAG integration next step</a:t>
                       </a:r>
                     </a:p>
                   </a:txBody>
@@ -7330,7 +7330,7 @@
                           <a:ea typeface="+mn-ea"/>
                           <a:cs typeface="+mn-cs"/>
                         </a:rPr>
-                        <a:t>On hold; bot accuracy takes priority</a:t>
+                        <a:t>On hold; chatbot accuracy prioritised first</a:t>
                       </a:r>
                     </a:p>
                   </a:txBody>
@@ -7828,7 +7828,7 @@
                 </a:solidFill>
                 <a:latin typeface="Avenir Book" panose="02000503020000020003"/>
               </a:rPr>
-              <a:t>Donna to share Rules document: deposits per service, cancellation policy, package details</a:t>
+              <a:t>Go-ahead needed to deploy SOP knowledge base into the live WhatsApp bot (production change)</a:t>
             </a:r>
           </a:p>
           <a:p>
@@ -7858,7 +7858,7 @@
                 </a:solidFill>
                 <a:latin typeface="Avenir Book" panose="02000503020000020003"/>
               </a:rPr>
-              <a:t>Go-ahead to deploy SOP knowledge base into the live WhatsApp bot (production change)</a:t>
+              <a:t>Confirm re-booking reminder message text per service before activating automated sends</a:t>
             </a:r>
           </a:p>
           <a:p>
@@ -7888,7 +7888,7 @@
                 </a:solidFill>
                 <a:latin typeface="Avenir Book" panose="02000503020000020003"/>
               </a:rPr>
-              <a:t>Confirm recovery WhatsApp message wording before approving go-live (TEST mode active)</a:t>
+              <a:t>Confirm phone recovery WhatsApp message wording for go-live (currently TEST mode only)</a:t>
             </a:r>
           </a:p>
         </p:txBody>

</xml_diff>

<commit_message>
CW26-27 Niumee weekly report - add AI Search Visibility achievement
</commit_message>
<xml_diff>
--- a/Niumee/Kaizen-CW26-27-Niumee-Weekly-Report.pptx
+++ b/Niumee/Kaizen-CW26-27-Niumee-Weekly-Report.pptx
@@ -5634,6 +5634,36 @@
               <a:t>Run Clarissa's 18-question regression test; fix staff assignments via Zenoti Employees API</a:t>
             </a:r>
           </a:p>
+          <a:p>
+            <a:pPr marL="285750" marR="0" lvl="0" indent="-285750" algn="l" defTabSz="914400" rtl="0" eaLnBrk="1" fontAlgn="auto" latinLnBrk="0" hangingPunct="1">
+              <a:lnSpc>
+                <a:spcPct val="100000"/>
+              </a:lnSpc>
+              <a:spcBef>
+                <a:spcPts val="400"/>
+              </a:spcBef>
+              <a:spcAft>
+                <a:spcPts val="0"/>
+              </a:spcAft>
+              <a:buClr>
+                <a:srgbClr val="916B2A"/>
+              </a:buClr>
+              <a:buSzTx/>
+              <a:buFont typeface="Wingdings" panose="05000000000000000000" pitchFamily="2" charset="2"/>
+              <a:buChar char="S"/>
+              <a:tabLst/>
+              <a:defRPr/>
+            </a:pPr>
+            <a:r>
+              <a:rPr lang="en-US" sz="1400" kern="0" dirty="0">
+                <a:solidFill>
+                  <a:srgbClr val="000000"/>
+                </a:solidFill>
+                <a:latin typeface="Avenir Book" panose="02000503020000020003"/>
+              </a:rPr>
+              <a:t>Hand off AI Search Visibility pack to website/backend team: treatment page content, schema markup, citation fixes</a:t>
+            </a:r>
+          </a:p>
         </p:txBody>
       </p:sp>
       <p:sp>
@@ -5751,6 +5781,36 @@
                 <a:latin typeface="Avenir Book" panose="02000503020000020003"/>
               </a:rPr>
               <a:t>KPI dashboard rebuilt: 90-day revenue by category + 4 weekly trend charts; load time 90s -&gt; 16s</a:t>
+            </a:r>
+          </a:p>
+          <a:p>
+            <a:pPr marL="285750" marR="0" lvl="0" indent="-285750" algn="l" defTabSz="914400" rtl="0" eaLnBrk="1" fontAlgn="auto" latinLnBrk="0" hangingPunct="1">
+              <a:lnSpc>
+                <a:spcPct val="100000"/>
+              </a:lnSpc>
+              <a:spcBef>
+                <a:spcPts val="400"/>
+              </a:spcBef>
+              <a:spcAft>
+                <a:spcPts val="0"/>
+              </a:spcAft>
+              <a:buClr>
+                <a:srgbClr val="916B2A"/>
+              </a:buClr>
+              <a:buSzTx/>
+              <a:buFont typeface="Wingdings" panose="05000000000000000000" pitchFamily="2" charset="2"/>
+              <a:buChar char="S"/>
+              <a:tabLst/>
+              <a:defRPr/>
+            </a:pPr>
+            <a:r>
+              <a:rPr lang="en-US" sz="1400" kern="0" dirty="0">
+                <a:solidFill>
+                  <a:srgbClr val="000000"/>
+                </a:solidFill>
+                <a:latin typeface="Avenir Book" panose="02000503020000020003"/>
+              </a:rPr>
+              <a:t>AI Search Visibility plan complete - treatment page template, schema checklist + citation audit ready to hand off to website team</a:t>
             </a:r>
           </a:p>
         </p:txBody>
@@ -7891,6 +7951,36 @@
               <a:t>Confirm phone recovery WhatsApp message wording for go-live (currently TEST mode only)</a:t>
             </a:r>
           </a:p>
+          <a:p>
+            <a:pPr marL="285750" marR="0" lvl="0" indent="-285750" algn="l" defTabSz="914400" rtl="0" eaLnBrk="1" fontAlgn="auto" latinLnBrk="0" hangingPunct="1">
+              <a:lnSpc>
+                <a:spcPct val="100000"/>
+              </a:lnSpc>
+              <a:spcBef>
+                <a:spcPts val="400"/>
+              </a:spcBef>
+              <a:spcAft>
+                <a:spcPts val="0"/>
+              </a:spcAft>
+              <a:buClr>
+                <a:srgbClr val="00B0E0"/>
+              </a:buClr>
+              <a:buSzTx/>
+              <a:buFont typeface="Wingdings" panose="05000000000000000000" pitchFamily="2" charset="2"/>
+              <a:buChar char="S"/>
+              <a:tabLst/>
+              <a:defRPr/>
+            </a:pPr>
+            <a:r>
+              <a:rPr lang="en-US" sz="1400" kern="0" dirty="0">
+                <a:solidFill>
+                  <a:srgbClr val="000000"/>
+                </a:solidFill>
+                <a:latin typeface="Avenir Book" panose="02000503020000020003"/>
+              </a:rPr>
+              <a:t>Confirm website team contact to receive AI Search Visibility implementation pack</a:t>
+            </a:r>
+          </a:p>
         </p:txBody>
       </p:sp>
       <p:sp>

</xml_diff>

<commit_message>
CW26-27 Niumee report - Donna/Maria audience, clinic language
</commit_message>
<xml_diff>
--- a/Niumee/Kaizen-CW26-27-Niumee-Weekly-Report.pptx
+++ b/Niumee/Kaizen-CW26-27-Niumee-Weekly-Report.pptx
@@ -5571,7 +5571,7 @@
                 </a:solidFill>
                 <a:latin typeface="Avenir Book" panose="02000503020000020003"/>
               </a:rPr>
-              <a:t>Implement re-booking reminder rules into the automation (rules document received, build ready)</a:t>
+              <a:t>Send the first automated re-booking reminders - message wording to be confirmed with Donna per service</a:t>
             </a:r>
           </a:p>
           <a:p>
@@ -5601,7 +5601,7 @@
                 </a:solidFill>
                 <a:latin typeface="Avenir Book" panose="02000503020000020003"/>
               </a:rPr>
-              <a:t>Wire SOP knowledge base into the live bot - 57 treatments extracted, RAG system ready to deploy</a:t>
+              <a:t>Connect the chatbot to the treatment guide so patients get accurate answers about NIUMEE services</a:t>
             </a:r>
           </a:p>
           <a:p>
@@ -5631,7 +5631,7 @@
                 </a:solidFill>
                 <a:latin typeface="Avenir Book" panose="02000503020000020003"/>
               </a:rPr>
-              <a:t>Run Clarissa's 18-question regression test; fix staff assignments via Zenoti Employees API</a:t>
+              <a:t>Test the chatbot on 18 real patient questions from the front desk</a:t>
             </a:r>
           </a:p>
           <a:p>
@@ -5661,7 +5661,7 @@
                 </a:solidFill>
                 <a:latin typeface="Avenir Book" panose="02000503020000020003"/>
               </a:rPr>
-              <a:t>Hand off AI Search Visibility pack to website/backend team: treatment page content, schema markup, citation fixes</a:t>
+              <a:t>Share AI visibility content with the website team so NIUMEE appears more in AI search results</a:t>
             </a:r>
           </a:p>
         </p:txBody>
@@ -5720,7 +5720,7 @@
                 </a:solidFill>
                 <a:latin typeface="Avenir Book" panose="02000503020000020003"/>
               </a:rPr>
-              <a:t>SOP updated + Donna's reminder rules received (June 30) - re-booking cadence per service now defined</a:t>
+              <a:t>Received the treatment guide and re-booking rules from Donna - we now know the right follow-up timing for each service</a:t>
             </a:r>
           </a:p>
           <a:p>
@@ -5750,7 +5750,7 @@
                 </a:solidFill>
                 <a:latin typeface="Avenir Book" panose="02000503020000020003"/>
               </a:rPr>
-              <a:t>Phone system API live - real-time missed-call tracker with Zenoti name resolution, TEST recovery active</a:t>
+              <a:t>Missed call tracker is running - every unanswered call is now logged with the patient name; follow-up message in testing</a:t>
             </a:r>
           </a:p>
           <a:p>
@@ -5780,7 +5780,7 @@
                 </a:solidFill>
                 <a:latin typeface="Avenir Book" panose="02000503020000020003"/>
               </a:rPr>
-              <a:t>KPI dashboard rebuilt: 90-day revenue by category + 4 weekly trend charts; load time 90s -&gt; 16s</a:t>
+              <a:t>Weekly performance report updated with 90 days of revenue by treatment category and 4 trend views</a:t>
             </a:r>
           </a:p>
           <a:p>
@@ -5810,7 +5810,7 @@
                 </a:solidFill>
                 <a:latin typeface="Avenir Book" panose="02000503020000020003"/>
               </a:rPr>
-              <a:t>AI Search Visibility plan complete - treatment page template, schema checklist + citation audit ready to hand off to website team</a:t>
+              <a:t>AI search visibility plan ready - NIUMEE content prepared so patients find the clinic when searching on ChatGPT or Google</a:t>
             </a:r>
           </a:p>
         </p:txBody>
@@ -6322,7 +6322,7 @@
                           <a:ea typeface="+mn-ea"/>
                           <a:cs typeface="+mn-cs"/>
                         </a:rPr>
-                        <a:t>KPI dashboard live - weekly and 90-day revenue views</a:t>
+                        <a:t>Weekly performance report live - revenue by treatment, 90-day view available</a:t>
                       </a:r>
                     </a:p>
                   </a:txBody>
@@ -6589,7 +6589,7 @@
                           <a:ea typeface="+mn-ea"/>
                           <a:cs typeface="+mn-cs"/>
                         </a:rPr>
-                        <a:t>Live; reminder rules received from Donna, integration next</a:t>
+                        <a:t>Live; re-booking rules received from Donna, pending message wording approval</a:t>
                       </a:r>
                     </a:p>
                   </a:txBody>
@@ -6856,7 +6856,7 @@
                           <a:ea typeface="+mn-ea"/>
                           <a:cs typeface="+mn-cs"/>
                         </a:rPr>
-                        <a:t>Phone API live; tracker in TEST mode, go-live pending</a:t>
+                        <a:t>Call tracker live; follow-up message in testing, patient go-live pending</a:t>
                       </a:r>
                     </a:p>
                   </a:txBody>
@@ -7123,7 +7123,7 @@
                           <a:ea typeface="+mn-ea"/>
                           <a:cs typeface="+mn-cs"/>
                         </a:rPr>
-                        <a:t>SOP KB built (57 treatments); RAG integration next step</a:t>
+                        <a:t>Treatment guide loaded (57 services); connecting to patient chatbot next</a:t>
                       </a:r>
                     </a:p>
                   </a:txBody>
@@ -7888,7 +7888,7 @@
                 </a:solidFill>
                 <a:latin typeface="Avenir Book" panose="02000503020000020003"/>
               </a:rPr>
-              <a:t>Go-ahead needed to deploy SOP knowledge base into the live WhatsApp bot (production change)</a:t>
+              <a:t>Approve chatbot connection to treatment guide (affects live patient conversations)</a:t>
             </a:r>
           </a:p>
           <a:p>
@@ -7918,7 +7918,7 @@
                 </a:solidFill>
                 <a:latin typeface="Avenir Book" panose="02000503020000020003"/>
               </a:rPr>
-              <a:t>Confirm re-booking reminder message text per service before activating automated sends</a:t>
+              <a:t>Confirm reminder message wording per service before first automated sends go out</a:t>
             </a:r>
           </a:p>
           <a:p>
@@ -7948,7 +7948,7 @@
                 </a:solidFill>
                 <a:latin typeface="Avenir Book" panose="02000503020000020003"/>
               </a:rPr>
-              <a:t>Confirm phone recovery WhatsApp message wording for go-live (currently TEST mode only)</a:t>
+              <a:t>Confirm missed-call follow-up message wording before going live with patients</a:t>
             </a:r>
           </a:p>
           <a:p>
@@ -7978,7 +7978,7 @@
                 </a:solidFill>
                 <a:latin typeface="Avenir Book" panose="02000503020000020003"/>
               </a:rPr>
-              <a:t>Confirm website team contact to receive AI Search Visibility implementation pack</a:t>
+              <a:t>Confirm who on the website team will handle the AI search visibility updates</a:t>
             </a:r>
           </a:p>
         </p:txBody>

</xml_diff>